<commit_message>
Meeting deck: dimensioned cross-sections, Fabry-Perot envelopes, cavity explanation, charts cut at 11 um
Co-Authored-By: Claude Opus 5.5 <noreply@anthropic.com>
Claude-Session: https://claude.ai/code/session_01EHQDy7yrZwCZyHELu6KFb3
</commit_message>
<xml_diff>
--- a/results/buffer/VPI_Lisbon_Lifted_buffer-meeting.pptx
+++ b/results/buffer/VPI_Lisbon_Lifted_buffer-meeting.pptx
@@ -156,6 +156,646 @@
               <c:strCache>
                 <c:ptCount val="1"/>
                 <c:pt idx="0">
+                  <c:v>Fabry–Pérot envelope</c:v>
+                </c:pt>
+              </c:strCache>
+            </c:strRef>
+          </c:tx>
+          <c:spPr>
+            <a:ln w="15875">
+              <a:solidFill>
+                <a:srgbClr val="8A8A8A"/>
+              </a:solidFill>
+            </a:ln>
+          </c:spPr>
+          <c:marker>
+            <c:symbol val="none"/>
+          </c:marker>
+          <c:xVal>
+            <c:numRef>
+              <c:f>Sheet1!$A$2:$A$47</c:f>
+              <c:numCache>
+                <c:formatCode>General</c:formatCode>
+                <c:ptCount val="46"/>
+                <c:pt idx="0">
+                  <c:v>6.5</c:v>
+                </c:pt>
+                <c:pt idx="1">
+                  <c:v>6.6</c:v>
+                </c:pt>
+                <c:pt idx="2">
+                  <c:v>6.7</c:v>
+                </c:pt>
+                <c:pt idx="3">
+                  <c:v>6.8</c:v>
+                </c:pt>
+                <c:pt idx="4">
+                  <c:v>6.9</c:v>
+                </c:pt>
+                <c:pt idx="5">
+                  <c:v>7.0</c:v>
+                </c:pt>
+                <c:pt idx="6">
+                  <c:v>7.1</c:v>
+                </c:pt>
+                <c:pt idx="7">
+                  <c:v>7.2</c:v>
+                </c:pt>
+                <c:pt idx="8">
+                  <c:v>7.3</c:v>
+                </c:pt>
+                <c:pt idx="9">
+                  <c:v>7.4</c:v>
+                </c:pt>
+                <c:pt idx="10">
+                  <c:v>7.5</c:v>
+                </c:pt>
+                <c:pt idx="11">
+                  <c:v>7.6</c:v>
+                </c:pt>
+                <c:pt idx="12">
+                  <c:v>7.7</c:v>
+                </c:pt>
+                <c:pt idx="13">
+                  <c:v>7.8</c:v>
+                </c:pt>
+                <c:pt idx="14">
+                  <c:v>7.9</c:v>
+                </c:pt>
+                <c:pt idx="15">
+                  <c:v>8.0</c:v>
+                </c:pt>
+                <c:pt idx="16">
+                  <c:v>8.1</c:v>
+                </c:pt>
+                <c:pt idx="17">
+                  <c:v>8.2</c:v>
+                </c:pt>
+                <c:pt idx="18">
+                  <c:v>8.3</c:v>
+                </c:pt>
+                <c:pt idx="19">
+                  <c:v>8.4</c:v>
+                </c:pt>
+                <c:pt idx="20">
+                  <c:v>8.5</c:v>
+                </c:pt>
+                <c:pt idx="21">
+                  <c:v>8.6</c:v>
+                </c:pt>
+                <c:pt idx="22">
+                  <c:v>8.7</c:v>
+                </c:pt>
+                <c:pt idx="23">
+                  <c:v>8.8</c:v>
+                </c:pt>
+                <c:pt idx="24">
+                  <c:v>8.9</c:v>
+                </c:pt>
+                <c:pt idx="25">
+                  <c:v>9.0</c:v>
+                </c:pt>
+                <c:pt idx="26">
+                  <c:v>9.1</c:v>
+                </c:pt>
+                <c:pt idx="27">
+                  <c:v>9.2</c:v>
+                </c:pt>
+                <c:pt idx="28">
+                  <c:v>9.3</c:v>
+                </c:pt>
+                <c:pt idx="29">
+                  <c:v>9.4</c:v>
+                </c:pt>
+                <c:pt idx="30">
+                  <c:v>9.5</c:v>
+                </c:pt>
+                <c:pt idx="31">
+                  <c:v>9.6</c:v>
+                </c:pt>
+                <c:pt idx="32">
+                  <c:v>9.7</c:v>
+                </c:pt>
+                <c:pt idx="33">
+                  <c:v>9.8</c:v>
+                </c:pt>
+                <c:pt idx="34">
+                  <c:v>9.9</c:v>
+                </c:pt>
+                <c:pt idx="35">
+                  <c:v>10.0</c:v>
+                </c:pt>
+                <c:pt idx="36">
+                  <c:v>10.1</c:v>
+                </c:pt>
+                <c:pt idx="37">
+                  <c:v>10.2</c:v>
+                </c:pt>
+                <c:pt idx="38">
+                  <c:v>10.3</c:v>
+                </c:pt>
+                <c:pt idx="39">
+                  <c:v>10.4</c:v>
+                </c:pt>
+                <c:pt idx="40">
+                  <c:v>10.5</c:v>
+                </c:pt>
+                <c:pt idx="41">
+                  <c:v>10.600000000000001</c:v>
+                </c:pt>
+                <c:pt idx="42">
+                  <c:v>10.7</c:v>
+                </c:pt>
+                <c:pt idx="43">
+                  <c:v>10.8</c:v>
+                </c:pt>
+                <c:pt idx="44">
+                  <c:v>10.9</c:v>
+                </c:pt>
+                <c:pt idx="45">
+                  <c:v>11.0</c:v>
+                </c:pt>
+              </c:numCache>
+            </c:numRef>
+          </c:xVal>
+          <c:yVal>
+            <c:numRef>
+              <c:f>Sheet1!$B$2:$B$47</c:f>
+              <c:numCache>
+                <c:formatCode>General</c:formatCode>
+                <c:ptCount val="46"/>
+                <c:pt idx="0">
+                  <c:v>1.006650587053012</c:v>
+                </c:pt>
+                <c:pt idx="1">
+                  <c:v>0.9890504365904927</c:v>
+                </c:pt>
+                <c:pt idx="2">
+                  <c:v>0.9721766277620217</c:v>
+                </c:pt>
+                <c:pt idx="3">
+                  <c:v>0.9559875457464122</c:v>
+                </c:pt>
+                <c:pt idx="4">
+                  <c:v>0.9404446835184903</c:v>
+                </c:pt>
+                <c:pt idx="5">
+                  <c:v>0.9255123568961874</c:v>
+                </c:pt>
+                <c:pt idx="6">
+                  <c:v>0.9111574503787427</c:v>
+                </c:pt>
+                <c:pt idx="7">
+                  <c:v>0.8973491899629845</c:v>
+                </c:pt>
+                <c:pt idx="8">
+                  <c:v>0.8840589396549298</c:v>
+                </c:pt>
+                <c:pt idx="9">
+                  <c:v>0.8712600188426537</c:v>
+                </c:pt>
+                <c:pt idx="10">
+                  <c:v>0.8589275380772697</c:v>
+                </c:pt>
+                <c:pt idx="11">
+                  <c:v>0.8470382511330767</c:v>
+                </c:pt>
+                <c:pt idx="12">
+                  <c:v>0.8355704214947759</c:v>
+                </c:pt>
+                <c:pt idx="13">
+                  <c:v>0.8245037016566026</c:v>
+                </c:pt>
+                <c:pt idx="14">
+                  <c:v>0.8138190238216242</c:v>
+                </c:pt>
+                <c:pt idx="15">
+                  <c:v>0.8034985007644893</c:v>
+                </c:pt>
+                <c:pt idx="16">
+                  <c:v>0.7935253357718876</c:v>
+                </c:pt>
+                <c:pt idx="17">
+                  <c:v>0.7838837407055548</c:v>
+                </c:pt>
+                <c:pt idx="18">
+                  <c:v>0.7745588613458081</c:v>
+                </c:pt>
+                <c:pt idx="19">
+                  <c:v>0.7655367092719055</c:v>
+                </c:pt>
+                <c:pt idx="20">
+                  <c:v>0.7568040996210808</c:v>
+                </c:pt>
+                <c:pt idx="21">
+                  <c:v>0.7483485941427807</c:v>
+                </c:pt>
+                <c:pt idx="22">
+                  <c:v>0.7401584490298743</c:v>
+                </c:pt>
+                <c:pt idx="23">
+                  <c:v>0.7322225670657726</c:v>
+                </c:pt>
+                <c:pt idx="24">
+                  <c:v>0.7245304536765667</c:v>
+                </c:pt>
+                <c:pt idx="25">
+                  <c:v>0.7170721765213897</c:v>
+                </c:pt>
+                <c:pt idx="26">
+                  <c:v>0.7098383282930668</c:v>
+                </c:pt>
+                <c:pt idx="27">
+                  <c:v>0.7028199924354015</c:v>
+                </c:pt>
+                <c:pt idx="28">
+                  <c:v>0.6960087115137353</c:v>
+                </c:pt>
+                <c:pt idx="29">
+                  <c:v>0.6893964580022703</c:v>
+                </c:pt>
+                <c:pt idx="30">
+                  <c:v>0.6829756072754077</c:v>
+                </c:pt>
+                <c:pt idx="31">
+                  <c:v>0.6767389126115225</c:v>
+                </c:pt>
+                <c:pt idx="32">
+                  <c:v>0.6706794820363629</c:v>
+                </c:pt>
+                <c:pt idx="33">
+                  <c:v>0.6647907568500406</c:v>
+                </c:pt>
+                <c:pt idx="34">
+                  <c:v>0.6590664916965068</c:v>
+                </c:pt>
+                <c:pt idx="35">
+                  <c:v>0.653500736047768</c:v>
+                </c:pt>
+                <c:pt idx="36">
+                  <c:v>0.6480878169870493</c:v>
+                </c:pt>
+                <c:pt idx="37">
+                  <c:v>0.6428223231858109</c:v>
+                </c:pt>
+                <c:pt idx="38">
+                  <c:v>0.6376990899791363</c:v>
+                </c:pt>
+                <c:pt idx="39">
+                  <c:v>0.6327131854526343</c:v>
+                </c:pt>
+                <c:pt idx="40">
+                  <c:v>0.6278598974617616</c:v>
+                </c:pt>
+                <c:pt idx="41">
+                  <c:v>0.6231347215114608</c:v>
+                </c:pt>
+                <c:pt idx="42">
+                  <c:v>0.6185333494303112</c:v>
+                </c:pt>
+                <c:pt idx="43">
+                  <c:v>0.6140516587790796</c:v>
+                </c:pt>
+                <c:pt idx="44">
+                  <c:v>0.6096857029387015</c:v>
+                </c:pt>
+                <c:pt idx="45">
+                  <c:v>0.6054317018273723</c:v>
+                </c:pt>
+              </c:numCache>
+            </c:numRef>
+          </c:yVal>
+          <c:smooth val="0"/>
+        </c:ser>
+        <c:ser>
+          <c:idx val="1"/>
+          <c:order val="1"/>
+          <c:tx>
+            <c:strRef>
+              <c:f>Sheet1!$B$49</c:f>
+              <c:strCache>
+                <c:ptCount val="1"/>
+                <c:pt idx="0">
+                  <c:v>envelope_lo</c:v>
+                </c:pt>
+              </c:strCache>
+            </c:strRef>
+          </c:tx>
+          <c:spPr>
+            <a:ln w="15875">
+              <a:solidFill>
+                <a:srgbClr val="8A8A8A"/>
+              </a:solidFill>
+            </a:ln>
+          </c:spPr>
+          <c:marker>
+            <c:symbol val="none"/>
+          </c:marker>
+          <c:xVal>
+            <c:numRef>
+              <c:f>Sheet1!$A$50:$A$95</c:f>
+              <c:numCache>
+                <c:formatCode>General</c:formatCode>
+                <c:ptCount val="46"/>
+                <c:pt idx="0">
+                  <c:v>6.5</c:v>
+                </c:pt>
+                <c:pt idx="1">
+                  <c:v>6.6</c:v>
+                </c:pt>
+                <c:pt idx="2">
+                  <c:v>6.7</c:v>
+                </c:pt>
+                <c:pt idx="3">
+                  <c:v>6.8</c:v>
+                </c:pt>
+                <c:pt idx="4">
+                  <c:v>6.9</c:v>
+                </c:pt>
+                <c:pt idx="5">
+                  <c:v>7.0</c:v>
+                </c:pt>
+                <c:pt idx="6">
+                  <c:v>7.1</c:v>
+                </c:pt>
+                <c:pt idx="7">
+                  <c:v>7.2</c:v>
+                </c:pt>
+                <c:pt idx="8">
+                  <c:v>7.3</c:v>
+                </c:pt>
+                <c:pt idx="9">
+                  <c:v>7.4</c:v>
+                </c:pt>
+                <c:pt idx="10">
+                  <c:v>7.5</c:v>
+                </c:pt>
+                <c:pt idx="11">
+                  <c:v>7.6</c:v>
+                </c:pt>
+                <c:pt idx="12">
+                  <c:v>7.7</c:v>
+                </c:pt>
+                <c:pt idx="13">
+                  <c:v>7.8</c:v>
+                </c:pt>
+                <c:pt idx="14">
+                  <c:v>7.9</c:v>
+                </c:pt>
+                <c:pt idx="15">
+                  <c:v>8.0</c:v>
+                </c:pt>
+                <c:pt idx="16">
+                  <c:v>8.1</c:v>
+                </c:pt>
+                <c:pt idx="17">
+                  <c:v>8.2</c:v>
+                </c:pt>
+                <c:pt idx="18">
+                  <c:v>8.3</c:v>
+                </c:pt>
+                <c:pt idx="19">
+                  <c:v>8.4</c:v>
+                </c:pt>
+                <c:pt idx="20">
+                  <c:v>8.5</c:v>
+                </c:pt>
+                <c:pt idx="21">
+                  <c:v>8.6</c:v>
+                </c:pt>
+                <c:pt idx="22">
+                  <c:v>8.7</c:v>
+                </c:pt>
+                <c:pt idx="23">
+                  <c:v>8.8</c:v>
+                </c:pt>
+                <c:pt idx="24">
+                  <c:v>8.9</c:v>
+                </c:pt>
+                <c:pt idx="25">
+                  <c:v>9.0</c:v>
+                </c:pt>
+                <c:pt idx="26">
+                  <c:v>9.1</c:v>
+                </c:pt>
+                <c:pt idx="27">
+                  <c:v>9.2</c:v>
+                </c:pt>
+                <c:pt idx="28">
+                  <c:v>9.3</c:v>
+                </c:pt>
+                <c:pt idx="29">
+                  <c:v>9.4</c:v>
+                </c:pt>
+                <c:pt idx="30">
+                  <c:v>9.5</c:v>
+                </c:pt>
+                <c:pt idx="31">
+                  <c:v>9.6</c:v>
+                </c:pt>
+                <c:pt idx="32">
+                  <c:v>9.7</c:v>
+                </c:pt>
+                <c:pt idx="33">
+                  <c:v>9.8</c:v>
+                </c:pt>
+                <c:pt idx="34">
+                  <c:v>9.9</c:v>
+                </c:pt>
+                <c:pt idx="35">
+                  <c:v>10.0</c:v>
+                </c:pt>
+                <c:pt idx="36">
+                  <c:v>10.1</c:v>
+                </c:pt>
+                <c:pt idx="37">
+                  <c:v>10.2</c:v>
+                </c:pt>
+                <c:pt idx="38">
+                  <c:v>10.3</c:v>
+                </c:pt>
+                <c:pt idx="39">
+                  <c:v>10.4</c:v>
+                </c:pt>
+                <c:pt idx="40">
+                  <c:v>10.5</c:v>
+                </c:pt>
+                <c:pt idx="41">
+                  <c:v>10.600000000000001</c:v>
+                </c:pt>
+                <c:pt idx="42">
+                  <c:v>10.7</c:v>
+                </c:pt>
+                <c:pt idx="43">
+                  <c:v>10.8</c:v>
+                </c:pt>
+                <c:pt idx="44">
+                  <c:v>10.9</c:v>
+                </c:pt>
+                <c:pt idx="45">
+                  <c:v>11.0</c:v>
+                </c:pt>
+              </c:numCache>
+            </c:numRef>
+          </c:xVal>
+          <c:yVal>
+            <c:numRef>
+              <c:f>Sheet1!$B$50:$B$95</c:f>
+              <c:numCache>
+                <c:formatCode>General</c:formatCode>
+                <c:ptCount val="46"/>
+                <c:pt idx="0">
+                  <c:v>0.1683091246190541</c:v>
+                </c:pt>
+                <c:pt idx="1">
+                  <c:v>0.17130418514167206</c:v>
+                </c:pt>
+                <c:pt idx="2">
+                  <c:v>0.1742774659108793</c:v>
+                </c:pt>
+                <c:pt idx="3">
+                  <c:v>0.17722875141837086</c:v>
+                </c:pt>
+                <c:pt idx="4">
+                  <c:v>0.18015783604652405</c:v>
+                </c:pt>
+                <c:pt idx="5">
+                  <c:v>0.183064524035473</c:v>
+                </c:pt>
+                <c:pt idx="6">
+                  <c:v>0.1859486294423896</c:v>
+                </c:pt>
+                <c:pt idx="7">
+                  <c:v>0.18880997609318423</c:v>
+                </c:pt>
+                <c:pt idx="8">
+                  <c:v>0.19164839752684534</c:v>
+                </c:pt>
+                <c:pt idx="9">
+                  <c:v>0.19446373693264526</c:v>
+                </c:pt>
+                <c:pt idx="10">
+                  <c:v>0.19725584708044072</c:v>
+                </c:pt>
+                <c:pt idx="11">
+                  <c:v>0.2000245902443085</c:v>
+                </c:pt>
+                <c:pt idx="12">
+                  <c:v>0.20276983811975283</c:v>
+                </c:pt>
+                <c:pt idx="13">
+                  <c:v>0.20549147173473162</c:v>
+                </c:pt>
+                <c:pt idx="14">
+                  <c:v>0.20818938135474863</c:v>
+                </c:pt>
+                <c:pt idx="15">
+                  <c:v>0.21086346638226022</c:v>
+                </c:pt>
+                <c:pt idx="16">
+                  <c:v>0.2135136352506512</c:v>
+                </c:pt>
+                <c:pt idx="17">
+                  <c:v>0.21613980531303137</c:v>
+                </c:pt>
+                <c:pt idx="18">
+                  <c:v>0.21874190272610752</c:v>
+                </c:pt>
+                <c:pt idx="19">
+                  <c:v>0.22131986232938605</c:v>
+                </c:pt>
+                <c:pt idx="20">
+                  <c:v>0.2238736275199611</c:v>
+                </c:pt>
+                <c:pt idx="21">
+                  <c:v>0.22640315012314077</c:v>
+                </c:pt>
+                <c:pt idx="22">
+                  <c:v>0.22890839025916584</c:v>
+                </c:pt>
+                <c:pt idx="23">
+                  <c:v>0.23138931620627073</c:v>
+                </c:pt>
+                <c:pt idx="24">
+                  <c:v>0.23384590426033755</c:v>
+                </c:pt>
+                <c:pt idx="25">
+                  <c:v>0.23627813859138824</c:v>
+                </c:pt>
+                <c:pt idx="26">
+                  <c:v>0.23868601109716125</c:v>
+                </c:pt>
+                <c:pt idx="27">
+                  <c:v>0.2410695212540103</c:v>
+                </c:pt>
+                <c:pt idx="28">
+                  <c:v>0.24342867596536652</c:v>
+                </c:pt>
+                <c:pt idx="29">
+                  <c:v>0.24576348940799375</c:v>
+                </c:pt>
+                <c:pt idx="30">
+                  <c:v>0.2480739828762696</c:v>
+                </c:pt>
+                <c:pt idx="31">
+                  <c:v>0.25036018462471454</c:v>
+                </c:pt>
+                <c:pt idx="32">
+                  <c:v>0.25262212970899156</c:v>
+                </c:pt>
+                <c:pt idx="33">
+                  <c:v>0.2548598598255902</c:v>
+                </c:pt>
+                <c:pt idx="34">
+                  <c:v>0.2570734231504056</c:v>
+                </c:pt>
+                <c:pt idx="35">
+                  <c:v>0.25926287417641847</c:v>
+                </c:pt>
+                <c:pt idx="36">
+                  <c:v>0.2614282735506738</c:v>
+                </c:pt>
+                <c:pt idx="37">
+                  <c:v>0.2635696879107529</c:v>
+                </c:pt>
+                <c:pt idx="38">
+                  <c:v>0.2656871897209271</c:v>
+                </c:pt>
+                <c:pt idx="39">
+                  <c:v>0.2677808571081738</c:v>
+                </c:pt>
+                <c:pt idx="40">
+                  <c:v>0.26985077369823257</c:v>
+                </c:pt>
+                <c:pt idx="41">
+                  <c:v>0.27189702845186936</c:v>
+                </c:pt>
+                <c:pt idx="42">
+                  <c:v>0.27391971550151395</c:v>
+                </c:pt>
+                <c:pt idx="43">
+                  <c:v>0.2759189339884276</c:v>
+                </c:pt>
+                <c:pt idx="44">
+                  <c:v>0.2778947879005519</c:v>
+                </c:pt>
+                <c:pt idx="45">
+                  <c:v>0.27984738591118374</c:v>
+                </c:pt>
+              </c:numCache>
+            </c:numRef>
+          </c:yVal>
+          <c:smooth val="0"/>
+        </c:ser>
+        <c:ser>
+          <c:idx val="2"/>
+          <c:order val="2"/>
+          <c:tx>
+            <c:strRef>
+              <c:f>Sheet1!$B$97</c:f>
+              <c:strCache>
+                <c:ptCount val="1"/>
+                <c:pt idx="0">
                   <c:v>Lisbon, lifted</c:v>
                 </c:pt>
               </c:strCache>
@@ -184,10 +824,10 @@
           </c:marker>
           <c:xVal>
             <c:numRef>
-              <c:f>Sheet1!$A$2:$A$48</c:f>
+              <c:f>Sheet1!$A$98:$A$143</c:f>
               <c:numCache>
                 <c:formatCode>General</c:formatCode>
-                <c:ptCount val="47"/>
+                <c:ptCount val="46"/>
                 <c:pt idx="0">
                   <c:v>6.5</c:v>
                 </c:pt>
@@ -325,19 +965,16 @@
                 </c:pt>
                 <c:pt idx="45">
                   <c:v>11.0</c:v>
-                </c:pt>
-                <c:pt idx="46">
-                  <c:v>12.1</c:v>
                 </c:pt>
               </c:numCache>
             </c:numRef>
           </c:xVal>
           <c:yVal>
             <c:numRef>
-              <c:f>Sheet1!$B$2:$B$48</c:f>
+              <c:f>Sheet1!$B$98:$B$143</c:f>
               <c:numCache>
                 <c:formatCode>General</c:formatCode>
-                <c:ptCount val="47"/>
+                <c:ptCount val="46"/>
                 <c:pt idx="0">
                   <c:v>0.6815</c:v>
                 </c:pt>
@@ -475,9 +1112,6 @@
                 </c:pt>
                 <c:pt idx="45">
                   <c:v>0.5169</c:v>
-                </c:pt>
-                <c:pt idx="46">
-                  <c:v>0.3284</c:v>
                 </c:pt>
               </c:numCache>
             </c:numRef>
@@ -485,15 +1119,15 @@
           <c:smooth val="0"/>
         </c:ser>
         <c:ser>
-          <c:idx val="1"/>
-          <c:order val="1"/>
+          <c:idx val="3"/>
+          <c:order val="3"/>
           <c:tx>
             <c:strRef>
-              <c:f>Sheet1!$B$50</c:f>
+              <c:f>Sheet1!$B$145</c:f>
               <c:strCache>
                 <c:ptCount val="1"/>
                 <c:pt idx="0">
-                  <c:v>Cordoba, legacy (0.42 dB/cm)</c:v>
+                  <c:v>Cordoba (0.42 dB/cm)</c:v>
                 </c:pt>
               </c:strCache>
             </c:strRef>
@@ -511,22 +1145,22 @@
           </c:marker>
           <c:xVal>
             <c:numRef>
-              <c:f>Sheet1!$A$51:$A$52</c:f>
+              <c:f>Sheet1!$A$146:$A$147</c:f>
               <c:numCache>
                 <c:formatCode>General</c:formatCode>
                 <c:ptCount val="2"/>
                 <c:pt idx="0">
-                  <c:v>6.0</c:v>
+                  <c:v>6.5</c:v>
                 </c:pt>
                 <c:pt idx="1">
-                  <c:v>12.5</c:v>
+                  <c:v>11.0</c:v>
                 </c:pt>
               </c:numCache>
             </c:numRef>
           </c:xVal>
           <c:yVal>
             <c:numRef>
-              <c:f>Sheet1!$B$51:$B$52</c:f>
+              <c:f>Sheet1!$B$146:$B$147</c:f>
               <c:numCache>
                 <c:formatCode>General</c:formatCode>
                 <c:ptCount val="2"/>
@@ -542,11 +1176,11 @@
           <c:smooth val="0"/>
         </c:ser>
         <c:ser>
-          <c:idx val="2"/>
-          <c:order val="2"/>
+          <c:idx val="4"/>
+          <c:order val="4"/>
           <c:tx>
             <c:strRef>
-              <c:f>Sheet1!$B$54</c:f>
+              <c:f>Sheet1!$B$149</c:f>
               <c:strCache>
                 <c:ptCount val="1"/>
                 <c:pt idx="0">
@@ -578,7 +1212,7 @@
           </c:marker>
           <c:xVal>
             <c:numRef>
-              <c:f>Sheet1!$A$55:$A$56</c:f>
+              <c:f>Sheet1!$A$150:$A$151</c:f>
               <c:numCache>
                 <c:formatCode>General</c:formatCode>
                 <c:ptCount val="2"/>
@@ -593,7 +1227,7 @@
           </c:xVal>
           <c:yVal>
             <c:numRef>
-              <c:f>Sheet1!$B$55:$B$56</c:f>
+              <c:f>Sheet1!$B$150:$B$151</c:f>
               <c:numCache>
                 <c:formatCode>General</c:formatCode>
                 <c:ptCount val="2"/>
@@ -615,8 +1249,8 @@
         <c:axId val="-2128940872"/>
         <c:scaling>
           <c:orientation val="minMax"/>
-          <c:max val="12.5"/>
-          <c:min val="6.0"/>
+          <c:max val="11.0"/>
+          <c:min val="6.5"/>
         </c:scaling>
         <c:delete val="0"/>
         <c:axPos val="b"/>
@@ -656,7 +1290,7 @@
         <c:crossAx val="-2129643912"/>
         <c:crosses val="autoZero"/>
         <c:crossBetween val="midCat"/>
-        <c:majorUnit val="1.0"/>
+        <c:majorUnit val="0.5"/>
       </c:valAx>
       <c:valAx>
         <c:axId val="-2129643912"/>
@@ -717,6 +1351,10 @@
     </c:plotArea>
     <c:legend>
       <c:legendPos val="t"/>
+      <c:legendEntry>
+        <c:idx val="1"/>
+        <c:delete val="1"/>
+      </c:legendEntry>
       <c:layout/>
       <c:overlay val="0"/>
       <c:txPr>
@@ -724,7 +1362,7 @@
         <a:lstStyle/>
         <a:p>
           <a:pPr>
-            <a:defRPr sz="1000">
+            <a:defRPr sz="900">
               <a:latin typeface="Arial"/>
             </a:defRPr>
           </a:pPr>
@@ -1332,10 +1970,10 @@
           </c:marker>
           <c:xVal>
             <c:numRef>
-              <c:f>Sheet1!$A$2:$A$84</c:f>
+              <c:f>Sheet1!$A$2:$A$74</c:f>
               <c:numCache>
                 <c:formatCode>General</c:formatCode>
-                <c:ptCount val="83"/>
+                <c:ptCount val="73"/>
                 <c:pt idx="0">
                   <c:v>3.8</c:v>
                 </c:pt>
@@ -1554,46 +2192,16 @@
                 </c:pt>
                 <c:pt idx="72">
                   <c:v>11.0</c:v>
-                </c:pt>
-                <c:pt idx="73">
-                  <c:v>11.1</c:v>
-                </c:pt>
-                <c:pt idx="74">
-                  <c:v>11.2</c:v>
-                </c:pt>
-                <c:pt idx="75">
-                  <c:v>11.3</c:v>
-                </c:pt>
-                <c:pt idx="76">
-                  <c:v>11.4</c:v>
-                </c:pt>
-                <c:pt idx="77">
-                  <c:v>11.5</c:v>
-                </c:pt>
-                <c:pt idx="78">
-                  <c:v>11.6</c:v>
-                </c:pt>
-                <c:pt idx="79">
-                  <c:v>11.7</c:v>
-                </c:pt>
-                <c:pt idx="80">
-                  <c:v>11.8</c:v>
-                </c:pt>
-                <c:pt idx="81">
-                  <c:v>11.9</c:v>
-                </c:pt>
-                <c:pt idx="82">
-                  <c:v>12.0</c:v>
                 </c:pt>
               </c:numCache>
             </c:numRef>
           </c:xVal>
           <c:yVal>
             <c:numRef>
-              <c:f>Sheet1!$B$2:$B$84</c:f>
+              <c:f>Sheet1!$B$2:$B$74</c:f>
               <c:numCache>
                 <c:formatCode>General</c:formatCode>
-                <c:ptCount val="83"/>
+                <c:ptCount val="73"/>
                 <c:pt idx="0">
                   <c:v>0.0481</c:v>
                 </c:pt>
@@ -1811,36 +2419,6 @@
                   <c:v>0.0481</c:v>
                 </c:pt>
                 <c:pt idx="72">
-                  <c:v>0.0481</c:v>
-                </c:pt>
-                <c:pt idx="73">
-                  <c:v>0.0481</c:v>
-                </c:pt>
-                <c:pt idx="74">
-                  <c:v>0.0481</c:v>
-                </c:pt>
-                <c:pt idx="75">
-                  <c:v>0.0481</c:v>
-                </c:pt>
-                <c:pt idx="76">
-                  <c:v>0.0481</c:v>
-                </c:pt>
-                <c:pt idx="77">
-                  <c:v>0.0481</c:v>
-                </c:pt>
-                <c:pt idx="78">
-                  <c:v>0.0481</c:v>
-                </c:pt>
-                <c:pt idx="79">
-                  <c:v>0.0481</c:v>
-                </c:pt>
-                <c:pt idx="80">
-                  <c:v>0.0481</c:v>
-                </c:pt>
-                <c:pt idx="81">
-                  <c:v>0.0481</c:v>
-                </c:pt>
-                <c:pt idx="82">
                   <c:v>0.0481</c:v>
                 </c:pt>
               </c:numCache>
@@ -1853,7 +2431,7 @@
           <c:order val="1"/>
           <c:tx>
             <c:strRef>
-              <c:f>Sheet1!$B$86</c:f>
+              <c:f>Sheet1!$B$76</c:f>
               <c:strCache>
                 <c:ptCount val="1"/>
                 <c:pt idx="0">
@@ -1885,10 +2463,10 @@
           </c:marker>
           <c:xVal>
             <c:numRef>
-              <c:f>Sheet1!$A$87:$A$133</c:f>
+              <c:f>Sheet1!$A$77:$A$122</c:f>
               <c:numCache>
                 <c:formatCode>General</c:formatCode>
-                <c:ptCount val="47"/>
+                <c:ptCount val="46"/>
                 <c:pt idx="0">
                   <c:v>6.5</c:v>
                 </c:pt>
@@ -2026,19 +2604,16 @@
                 </c:pt>
                 <c:pt idx="45">
                   <c:v>11.0</c:v>
-                </c:pt>
-                <c:pt idx="46">
-                  <c:v>12.1</c:v>
                 </c:pt>
               </c:numCache>
             </c:numRef>
           </c:xVal>
           <c:yVal>
             <c:numRef>
-              <c:f>Sheet1!$B$87:$B$133</c:f>
+              <c:f>Sheet1!$B$77:$B$122</c:f>
               <c:numCache>
                 <c:formatCode>General</c:formatCode>
-                <c:ptCount val="47"/>
+                <c:ptCount val="46"/>
                 <c:pt idx="0">
                   <c:v>0.6815</c:v>
                 </c:pt>
@@ -2176,9 +2751,6 @@
                 </c:pt>
                 <c:pt idx="45">
                   <c:v>0.5169</c:v>
-                </c:pt>
-                <c:pt idx="46">
-                  <c:v>0.3284</c:v>
                 </c:pt>
               </c:numCache>
             </c:numRef>
@@ -2192,7 +2764,7 @@
         <c:axId val="-2128940872"/>
         <c:scaling>
           <c:orientation val="minMax"/>
-          <c:max val="12.6"/>
+          <c:max val="11.0"/>
           <c:min val="3.5"/>
         </c:scaling>
         <c:delete val="0"/>
@@ -3737,7 +4309,7 @@
           <a:lstStyle/>
           <a:p>
             <a:r>
-              <a:t>Geometries drawn from the model polygons, same scale. x_lift = distance from the rib centre to the point where the gold leaves the LN slab and climbs onto the SiO2 lift. Vpi*L: Cordoba 2.260, Lisbon 2.265 V*cm at the same 4.2 um gap. IL of Lisbon oscillates between 0.18 and 0.88 dB/cm with a 0.9 um period around the Cordoba value 0.42 dB/cm. Red points: 7.1 -&gt; 7.2 um, the steepest 100 nm step (0.33 -&gt; 0.60 dB/cm). Lithography/overlay errors of this size are realistic, so the IL of a fabricated device is not predictable. Data: results/lift_sweep.csv.</a:t>
+              <a:t>Cross-sections drawn from the model polygons, same scale; dimensions in um. x_lift = distance from the rib centre to the point where the gold leaves the LN slab and climbs onto the SiO2 lift. Vpi*L: Cordoba 2.260, Lisbon 2.265 V*cm at the same 4.2 um gap. IL of Lisbon oscillates with a 0.9 um period around the Cordoba value; the steepest 100 nm step is 7.1 -&gt; 7.2 um (0.33 -&gt; 0.60 dB/cm), so the IL of a fabricated device is not predictable. Envelopes: the rib mode leaks into the wave guided under the gold, which bounces between two cut-off regions (gap edge and lift). The leakage rate is that of a source inside a Fabry-Perot cavity (Airy function), with round-trip factor rho = rho0*exp(-2*alpha*L), where alpha = Im(k_x) is the gold absorption of the lateral wave. Peaks (1+rho)/(1-rho) and dips (1-rho)/(1+rho) times IL_inf, so peak*dip = IL_inf^2 (measured sqrt(P*D) = 0.40-0.41 at every period) and both converge to IL_inf when the step is far. Free fit of all 46 points 6.5-11 um: IL_inf 0.412, rho0 0.91, 2*alpha 0.175 1/um, period 0.895 um. Independent 1D prediction from the complex index of the gold-guided wave (2.072 - 0.0095i) and n_rib 1.8834: 2*alpha 0.181 1/um, period 0.91 um. Data: results/lift_sweep.csv (beyond 11 um only sparse points, not shown).</a:t>
             </a:r>
           </a:p>
         </p:txBody>
@@ -3807,7 +4379,7 @@
           <a:lstStyle/>
           <a:p>
             <a:r>
-              <a:t>Left: |E|^2 at slab mid-height vs x. Dip (x_lift 6.9 um, IL 0.18) and peak (7.3 um, IL 0.88) show ripples between the gap edge and the lift; legacy (no lift) shows a smooth, slowly decaying travelling wave. Right: field maps, same dB scale. The gold/LN interface supports a lossy surface wave with index about 2.07, above the rib mode index 1.884, so it is phase-matched to leak sideways. The step where the gold leaves the slab reflects it; the reflected wave interferes with the incoming one. Ripple period 0.90 um = pi/k_x predicted by a 1D model (0.91 um).</a:t>
+              <a:t>Top left: |E|^2 at slab mid-height vs x. Dip (x_lift 6.9 um, IL 0.18) and peak (7.3 um, IL 0.88) show ripples between the gap edge and the lift; Cordoba shows a smooth, slowly decaying travelling wave. Right: field maps, same dB scale. Indices: 1D mode solve of each vertical stack (TM-like wave under the gold: Au / 275 nm LN slab / SiO2 BOX, n = 2.065-2.080 depending on the in-plane LN permittivity; gold-free slab with air or SiO2 on top: TE 1.70-1.80, TM 1.48-1.60). Rib mode: 2D FEM n_eff 1.8834. n &gt; n_rib alone gives lateral leakage (a travelling wave, as in Cordoba, where 30 um of gold absorbs it: round trip attenuation e^-5). The standing wave needs the second mirror: in Lisbon the slab beyond x_lift has no gold, so the wave is cut off there and reflected. The gap edge is also cut off, so the wave bounces between two mirrors. Interference: at the dip the reflected wave returns out of phase at the gap edge and suppresses the leakage (destructive); at the peak it returns in phase and enhances it (constructive). Fringe period inside the cavity and IL period vs x_lift are both pi/k_x: the cavity length fixes the order m, not the spacing (as in a Fabry-Perot, where resonances are spaced by half a wavelength in length).</a:t>
             </a:r>
           </a:p>
         </p:txBody>
@@ -3877,7 +4449,7 @@
           <a:lstStyle/>
           <a:p>
             <a:r>
-              <a:t>Chart top right: 1D effective index of the wave guided under the gold vs buffer thickness (mean of the two in-plane LN permittivities; cutoff 37-39 nm). Below the rib index the wave cannot be phase matched, so the rib mode cannot couple into a propagating wave: there is no standing wave to form, whatever x_lift. The 1D model matches the 2D simulations (period 0.90 vs 0.91 um at 0 nm; decay 28.98 vs 28.95 dB/um at 200 nm). Bottom: 200 nm buffer, 88 lift positions 3.8-30.1 um, IL 0.0480-0.0481 dB/cm. Chart shows up to 12.6 um; flat also at 16-30 um. Without buffer at gap 3.2 IL would be 4-30 dB/cm and still oscillating.</a:t>
+              <a:t>Chart top right: 1D effective index of the wave guided under the gold vs buffer thickness (mean of the two in-plane LN permittivities; cutoff 37-39 nm). Below the rib index the wave cannot be phase matched, so the rib mode cannot couple into a propagating wave: there is no standing wave to form, whatever x_lift. The 1D model matches the 2D simulations (period 0.90 vs 0.91 um at 0 nm; decay 28.98 vs 28.95 dB/um at 200 nm). Bottom: 200 nm buffer, 88 lift positions 3.8-30.1 um, IL 0.0480-0.0481 dB/cm. Chart shows up to 11 um; flat also at 12-30 um. Without buffer at gap 3.2 IL would be 4-30 dB/cm and still oscillating.</a:t>
             </a:r>
           </a:p>
         </p:txBody>
@@ -7747,8 +8319,8 @@
         </p:nvSpPr>
         <p:spPr>
           <a:xfrm>
-            <a:off x="457200" y="1645920"/>
-            <a:ext cx="5486400" cy="292608"/>
+            <a:off x="411480" y="1536192"/>
+            <a:ext cx="5943600" cy="292608"/>
           </a:xfrm>
           <a:prstGeom prst="rect">
             <a:avLst/>
@@ -7780,7 +8352,7 @@
       </p:sp>
       <p:pic>
         <p:nvPicPr>
-          <p:cNvPr id="5" name="Picture 4" descr="geom_legacy.png"/>
+          <p:cNvPr id="5" name="Picture 4" descr="geomd_legacy.png"/>
           <p:cNvPicPr>
             <a:picLocks noChangeAspect="1"/>
           </p:cNvPicPr>
@@ -7794,8 +8366,8 @@
         </p:blipFill>
         <p:spPr>
           <a:xfrm>
-            <a:off x="457200" y="1956816"/>
-            <a:ext cx="5486400" cy="827639"/>
+            <a:off x="411480" y="1810512"/>
+            <a:ext cx="5943600" cy="984504"/>
           </a:xfrm>
           <a:prstGeom prst="rect">
             <a:avLst/>
@@ -7810,8 +8382,8 @@
         </p:nvSpPr>
         <p:spPr>
           <a:xfrm>
-            <a:off x="457200" y="2898648"/>
-            <a:ext cx="5486400" cy="292608"/>
+            <a:off x="411480" y="2852928"/>
+            <a:ext cx="5943600" cy="292608"/>
           </a:xfrm>
           <a:prstGeom prst="rect">
             <a:avLst/>
@@ -7843,7 +8415,7 @@
       </p:sp>
       <p:pic>
         <p:nvPicPr>
-          <p:cNvPr id="7" name="Picture 6" descr="geom_lifted.png"/>
+          <p:cNvPr id="7" name="Picture 6" descr="geomd_lifted.png"/>
           <p:cNvPicPr>
             <a:picLocks noChangeAspect="1"/>
           </p:cNvPicPr>
@@ -7857,8 +8429,8 @@
         </p:blipFill>
         <p:spPr>
           <a:xfrm>
-            <a:off x="457200" y="3200400"/>
-            <a:ext cx="5486400" cy="1763486"/>
+            <a:off x="411480" y="3108960"/>
+            <a:ext cx="5943600" cy="1996440"/>
           </a:xfrm>
           <a:prstGeom prst="rect">
             <a:avLst/>
@@ -7873,8 +8445,8 @@
         </p:nvSpPr>
         <p:spPr>
           <a:xfrm>
-            <a:off x="457200" y="5166360"/>
-            <a:ext cx="2651760" cy="1143000"/>
+            <a:off x="411480" y="5285232"/>
+            <a:ext cx="2880360" cy="1097280"/>
           </a:xfrm>
           <a:prstGeom prst="roundRect">
             <a:avLst>
@@ -7919,8 +8491,8 @@
         </p:nvSpPr>
         <p:spPr>
           <a:xfrm>
-            <a:off x="457200" y="5202936"/>
-            <a:ext cx="2651760" cy="594360"/>
+            <a:off x="411480" y="5321808"/>
+            <a:ext cx="2880360" cy="570585"/>
           </a:xfrm>
           <a:prstGeom prst="rect">
             <a:avLst/>
@@ -7958,8 +8530,8 @@
         </p:nvSpPr>
         <p:spPr>
           <a:xfrm>
-            <a:off x="530352" y="5783580"/>
-            <a:ext cx="2505456" cy="502920"/>
+            <a:off x="484632" y="5877763"/>
+            <a:ext cx="2734056" cy="482803"/>
           </a:xfrm>
           <a:prstGeom prst="rect">
             <a:avLst/>
@@ -8013,8 +8585,8 @@
         </p:nvSpPr>
         <p:spPr>
           <a:xfrm>
-            <a:off x="3291840" y="5166360"/>
-            <a:ext cx="2651760" cy="1143000"/>
+            <a:off x="3474720" y="5285232"/>
+            <a:ext cx="2880360" cy="1097280"/>
           </a:xfrm>
           <a:prstGeom prst="roundRect">
             <a:avLst>
@@ -8059,8 +8631,8 @@
         </p:nvSpPr>
         <p:spPr>
           <a:xfrm>
-            <a:off x="3291840" y="5202936"/>
-            <a:ext cx="2651760" cy="594360"/>
+            <a:off x="3474720" y="5321808"/>
+            <a:ext cx="2880360" cy="570585"/>
           </a:xfrm>
           <a:prstGeom prst="rect">
             <a:avLst/>
@@ -8081,11 +8653,11 @@
             <a:r>
               <a:rPr sz="2600" b="1" i="0">
                 <a:solidFill>
-                  <a:srgbClr val="1F4E79"/>
+                  <a:srgbClr val="C0262D"/>
                 </a:solidFill>
                 <a:latin typeface="Arial"/>
               </a:rPr>
-              <a:t>x_lift</a:t>
+              <a:t>+80 %</a:t>
             </a:r>
           </a:p>
         </p:txBody>
@@ -8098,8 +8670,8 @@
         </p:nvSpPr>
         <p:spPr>
           <a:xfrm>
-            <a:off x="3364992" y="5783580"/>
-            <a:ext cx="2505456" cy="502920"/>
+            <a:off x="3547872" y="5877763"/>
+            <a:ext cx="2734056" cy="482803"/>
           </a:xfrm>
           <a:prstGeom prst="rect">
             <a:avLst/>
@@ -8124,7 +8696,7 @@
                 </a:solidFill>
                 <a:latin typeface="Arial"/>
               </a:rPr>
-              <a:t>distance from the rib centre</a:t>
+              <a:t>IL for a 100 nm shift of x_lift</a:t>
             </a:r>
           </a:p>
           <a:p>
@@ -8140,7 +8712,7 @@
                 </a:solidFill>
                 <a:latin typeface="Arial"/>
               </a:rPr>
-              <a:t>to the gold/oxide step</a:t>
+              <a:t>(7.1 → 7.2 µm: 0.33 → 0.60 dB/cm)</a:t>
             </a:r>
           </a:p>
         </p:txBody>
@@ -8154,8 +8726,8 @@
           <p:nvPr/>
         </p:nvGraphicFramePr>
         <p:xfrm>
-          <a:off x="6263640" y="1554480"/>
-          <a:ext cx="5532120" cy="3520440"/>
+          <a:off x="6537960" y="1481328"/>
+          <a:ext cx="5303520" cy="3063240"/>
         </p:xfrm>
         <a:graphic>
           <a:graphicData uri="http://schemas.openxmlformats.org/drawingml/2006/chart">
@@ -8171,432 +8743,8 @@
         </p:nvSpPr>
         <p:spPr>
           <a:xfrm>
-            <a:off x="6355080" y="5166360"/>
-            <a:ext cx="2606040" cy="1143000"/>
-          </a:xfrm>
-          <a:prstGeom prst="roundRect">
-            <a:avLst>
-              <a:gd name="adj" fmla="val 8000"/>
-            </a:avLst>
-          </a:prstGeom>
-          <a:solidFill>
-            <a:srgbClr val="EAF0F7"/>
-          </a:solidFill>
-          <a:ln>
-            <a:noFill/>
-          </a:ln>
-          <a:effectLst/>
-        </p:spPr>
-        <p:style>
-          <a:lnRef idx="1">
-            <a:schemeClr val="accent1"/>
-          </a:lnRef>
-          <a:fillRef idx="3">
-            <a:schemeClr val="accent1"/>
-          </a:fillRef>
-          <a:effectRef idx="2">
-            <a:schemeClr val="accent1"/>
-          </a:effectRef>
-          <a:fontRef idx="minor">
-            <a:schemeClr val="lt1"/>
-          </a:fontRef>
-        </p:style>
-        <p:txBody>
-          <a:bodyPr rtlCol="0" anchor="ctr"/>
-          <a:lstStyle/>
-          <a:p>
-            <a:pPr algn="ctr"/>
-          </a:p>
-        </p:txBody>
-      </p:sp>
-      <p:sp>
-        <p:nvSpPr>
-          <p:cNvPr id="16" name="TextBox 15"/>
-          <p:cNvSpPr txBox="1"/>
-          <p:nvPr/>
-        </p:nvSpPr>
-        <p:spPr>
-          <a:xfrm>
-            <a:off x="6355080" y="5202936"/>
-            <a:ext cx="2606040" cy="594360"/>
-          </a:xfrm>
-          <a:prstGeom prst="rect">
-            <a:avLst/>
-          </a:prstGeom>
-          <a:noFill/>
-        </p:spPr>
-        <p:txBody>
-          <a:bodyPr wrap="square" lIns="45720" rIns="45720" tIns="27432" bIns="27432" anchor="ctr">
-            <a:spAutoFit/>
-          </a:bodyPr>
-          <a:lstStyle/>
-          <a:p>
-            <a:pPr algn="ctr">
-              <a:spcAft>
-                <a:spcPts val="0"/>
-              </a:spcAft>
-            </a:pPr>
-            <a:r>
-              <a:rPr sz="2600" b="1" i="0">
-                <a:solidFill>
-                  <a:srgbClr val="C0262D"/>
-                </a:solidFill>
-                <a:latin typeface="Arial"/>
-              </a:rPr>
-              <a:t>+80 %</a:t>
-            </a:r>
-          </a:p>
-        </p:txBody>
-      </p:sp>
-      <p:sp>
-        <p:nvSpPr>
-          <p:cNvPr id="17" name="TextBox 16"/>
-          <p:cNvSpPr txBox="1"/>
-          <p:nvPr/>
-        </p:nvSpPr>
-        <p:spPr>
-          <a:xfrm>
-            <a:off x="6428232" y="5783580"/>
-            <a:ext cx="2459736" cy="502920"/>
-          </a:xfrm>
-          <a:prstGeom prst="rect">
-            <a:avLst/>
-          </a:prstGeom>
-          <a:noFill/>
-        </p:spPr>
-        <p:txBody>
-          <a:bodyPr wrap="square" lIns="45720" rIns="45720" tIns="27432" bIns="27432" anchor="t">
-            <a:spAutoFit/>
-          </a:bodyPr>
-          <a:lstStyle/>
-          <a:p>
-            <a:pPr algn="ctr">
-              <a:spcAft>
-                <a:spcPts val="0"/>
-              </a:spcAft>
-            </a:pPr>
-            <a:r>
-              <a:rPr sz="1100" b="0" i="0">
-                <a:solidFill>
-                  <a:srgbClr val="595959"/>
-                </a:solidFill>
-                <a:latin typeface="Arial"/>
-              </a:rPr>
-              <a:t>IL for a 100 nm shift of x_lift</a:t>
-            </a:r>
-          </a:p>
-          <a:p>
-            <a:pPr algn="ctr">
-              <a:spcAft>
-                <a:spcPts val="0"/>
-              </a:spcAft>
-            </a:pPr>
-            <a:r>
-              <a:rPr sz="1100" b="0" i="0">
-                <a:solidFill>
-                  <a:srgbClr val="595959"/>
-                </a:solidFill>
-                <a:latin typeface="Arial"/>
-              </a:rPr>
-              <a:t>(0.33 → 0.60 dB/cm)</a:t>
-            </a:r>
-          </a:p>
-        </p:txBody>
-      </p:sp>
-      <p:sp>
-        <p:nvSpPr>
-          <p:cNvPr id="18" name="Rounded Rectangle 17"/>
-          <p:cNvSpPr/>
-          <p:nvPr/>
-        </p:nvSpPr>
-        <p:spPr>
-          <a:xfrm>
-            <a:off x="9144000" y="5166360"/>
-            <a:ext cx="2606040" cy="1143000"/>
-          </a:xfrm>
-          <a:prstGeom prst="roundRect">
-            <a:avLst>
-              <a:gd name="adj" fmla="val 8000"/>
-            </a:avLst>
-          </a:prstGeom>
-          <a:solidFill>
-            <a:srgbClr val="EAF0F7"/>
-          </a:solidFill>
-          <a:ln>
-            <a:noFill/>
-          </a:ln>
-          <a:effectLst/>
-        </p:spPr>
-        <p:style>
-          <a:lnRef idx="1">
-            <a:schemeClr val="accent1"/>
-          </a:lnRef>
-          <a:fillRef idx="3">
-            <a:schemeClr val="accent1"/>
-          </a:fillRef>
-          <a:effectRef idx="2">
-            <a:schemeClr val="accent1"/>
-          </a:effectRef>
-          <a:fontRef idx="minor">
-            <a:schemeClr val="lt1"/>
-          </a:fontRef>
-        </p:style>
-        <p:txBody>
-          <a:bodyPr rtlCol="0" anchor="ctr"/>
-          <a:lstStyle/>
-          <a:p>
-            <a:pPr algn="ctr"/>
-          </a:p>
-        </p:txBody>
-      </p:sp>
-      <p:sp>
-        <p:nvSpPr>
-          <p:cNvPr id="19" name="TextBox 18"/>
-          <p:cNvSpPr txBox="1"/>
-          <p:nvPr/>
-        </p:nvSpPr>
-        <p:spPr>
-          <a:xfrm>
-            <a:off x="9144000" y="5202936"/>
-            <a:ext cx="2606040" cy="594360"/>
-          </a:xfrm>
-          <a:prstGeom prst="rect">
-            <a:avLst/>
-          </a:prstGeom>
-          <a:noFill/>
-        </p:spPr>
-        <p:txBody>
-          <a:bodyPr wrap="square" lIns="45720" rIns="45720" tIns="27432" bIns="27432" anchor="ctr">
-            <a:spAutoFit/>
-          </a:bodyPr>
-          <a:lstStyle/>
-          <a:p>
-            <a:pPr algn="ctr">
-              <a:spcAft>
-                <a:spcPts val="0"/>
-              </a:spcAft>
-            </a:pPr>
-            <a:r>
-              <a:rPr sz="2600" b="1" i="0">
-                <a:solidFill>
-                  <a:srgbClr val="C0262D"/>
-                </a:solidFill>
-                <a:latin typeface="Arial"/>
-              </a:rPr>
-              <a:t>0.18 – 0.88</a:t>
-            </a:r>
-          </a:p>
-        </p:txBody>
-      </p:sp>
-      <p:sp>
-        <p:nvSpPr>
-          <p:cNvPr id="20" name="TextBox 19"/>
-          <p:cNvSpPr txBox="1"/>
-          <p:nvPr/>
-        </p:nvSpPr>
-        <p:spPr>
-          <a:xfrm>
-            <a:off x="9217152" y="5783580"/>
-            <a:ext cx="2459736" cy="502920"/>
-          </a:xfrm>
-          <a:prstGeom prst="rect">
-            <a:avLst/>
-          </a:prstGeom>
-          <a:noFill/>
-        </p:spPr>
-        <p:txBody>
-          <a:bodyPr wrap="square" lIns="45720" rIns="45720" tIns="27432" bIns="27432" anchor="t">
-            <a:spAutoFit/>
-          </a:bodyPr>
-          <a:lstStyle/>
-          <a:p>
-            <a:pPr algn="ctr">
-              <a:spcAft>
-                <a:spcPts val="0"/>
-              </a:spcAft>
-            </a:pPr>
-            <a:r>
-              <a:rPr sz="1100" b="0" i="0">
-                <a:solidFill>
-                  <a:srgbClr val="595959"/>
-                </a:solidFill>
-                <a:latin typeface="Arial"/>
-              </a:rPr>
-              <a:t>IL range [dB/cm] within</a:t>
-            </a:r>
-          </a:p>
-          <a:p>
-            <a:pPr algn="ctr">
-              <a:spcAft>
-                <a:spcPts val="0"/>
-              </a:spcAft>
-            </a:pPr>
-            <a:r>
-              <a:rPr sz="1100" b="0" i="0">
-                <a:solidFill>
-                  <a:srgbClr val="595959"/>
-                </a:solidFill>
-                <a:latin typeface="Arial"/>
-              </a:rPr>
-              <a:t>0.4 µm of x_lift (period 0.9 µm)</a:t>
-            </a:r>
-          </a:p>
-        </p:txBody>
-      </p:sp>
-    </p:spTree>
-  </p:cSld>
-  <p:clrMapOvr>
-    <a:masterClrMapping/>
-  </p:clrMapOvr>
-</p:sld>
-</file>
-
-<file path=ppt/slides/slide3.xml><?xml version="1.0" encoding="utf-8"?>
-<p:sld xmlns:a="http://schemas.openxmlformats.org/drawingml/2006/main" xmlns:p="http://schemas.openxmlformats.org/presentationml/2006/main" xmlns:r="http://schemas.openxmlformats.org/officeDocument/2006/relationships">
-  <p:cSld>
-    <p:spTree>
-      <p:nvGrpSpPr>
-        <p:cNvPr id="1" name=""/>
-        <p:cNvGrpSpPr/>
-        <p:nvPr/>
-      </p:nvGrpSpPr>
-      <p:grpSpPr/>
-      <p:sp>
-        <p:nvSpPr>
-          <p:cNvPr id="2" name="TextBox 1"/>
-          <p:cNvSpPr txBox="1"/>
-          <p:nvPr/>
-        </p:nvSpPr>
-        <p:spPr>
-          <a:xfrm>
-            <a:off x="502920" y="475488"/>
-            <a:ext cx="10241280" cy="685800"/>
-          </a:xfrm>
-          <a:prstGeom prst="rect">
-            <a:avLst/>
-          </a:prstGeom>
-          <a:noFill/>
-        </p:spPr>
-        <p:txBody>
-          <a:bodyPr wrap="square" lIns="45720" rIns="45720" tIns="27432" bIns="27432" anchor="ctr">
-            <a:spAutoFit/>
-          </a:bodyPr>
-          <a:lstStyle/>
-          <a:p>
-            <a:pPr algn="l">
-              <a:spcAft>
-                <a:spcPts val="600"/>
-              </a:spcAft>
-            </a:pPr>
-            <a:r>
-              <a:rPr sz="3000" b="0" i="0">
-                <a:solidFill>
-                  <a:srgbClr val="222222"/>
-                </a:solidFill>
-                <a:latin typeface="Arial"/>
-              </a:rPr>
-              <a:t>Origin: a standing wave under the gold</a:t>
-            </a:r>
-          </a:p>
-        </p:txBody>
-      </p:sp>
-      <p:sp>
-        <p:nvSpPr>
-          <p:cNvPr id="3" name="TextBox 2"/>
-          <p:cNvSpPr txBox="1"/>
-          <p:nvPr/>
-        </p:nvSpPr>
-        <p:spPr>
-          <a:xfrm>
-            <a:off x="502920" y="1115568"/>
-            <a:ext cx="10789920" cy="411480"/>
-          </a:xfrm>
-          <a:prstGeom prst="rect">
-            <a:avLst/>
-          </a:prstGeom>
-          <a:noFill/>
-        </p:spPr>
-        <p:txBody>
-          <a:bodyPr wrap="square" lIns="45720" rIns="45720" tIns="27432" bIns="27432" anchor="t">
-            <a:spAutoFit/>
-          </a:bodyPr>
-          <a:lstStyle/>
-          <a:p>
-            <a:pPr algn="l">
-              <a:spcAft>
-                <a:spcPts val="600"/>
-              </a:spcAft>
-            </a:pPr>
-            <a:r>
-              <a:rPr sz="1500" b="0" i="1">
-                <a:solidFill>
-                  <a:srgbClr val="595959"/>
-                </a:solidFill>
-                <a:latin typeface="Arial"/>
-              </a:rPr>
-              <a:t>|E|² along the slab: ripples appear under the gold in the lifted design, not in the legacy one</a:t>
-            </a:r>
-          </a:p>
-        </p:txBody>
-      </p:sp>
-      <p:pic>
-        <p:nvPicPr>
-          <p:cNvPr id="4" name="Picture 3" descr="image5.png"/>
-          <p:cNvPicPr>
-            <a:picLocks noChangeAspect="1"/>
-          </p:cNvPicPr>
-          <p:nvPr/>
-        </p:nvPicPr>
-        <p:blipFill>
-          <a:blip r:embed="rId2"/>
-          <a:stretch>
-            <a:fillRect/>
-          </a:stretch>
-        </p:blipFill>
-        <p:spPr>
-          <a:xfrm>
-            <a:off x="320040" y="1600200"/>
-            <a:ext cx="6629400" cy="2696636"/>
-          </a:xfrm>
-          <a:prstGeom prst="rect">
-            <a:avLst/>
-          </a:prstGeom>
-        </p:spPr>
-      </p:pic>
-      <p:pic>
-        <p:nvPicPr>
-          <p:cNvPr id="5" name="Picture 4" descr="image6.png"/>
-          <p:cNvPicPr>
-            <a:picLocks noChangeAspect="1"/>
-          </p:cNvPicPr>
-          <p:nvPr/>
-        </p:nvPicPr>
-        <p:blipFill>
-          <a:blip r:embed="rId3"/>
-          <a:stretch>
-            <a:fillRect/>
-          </a:stretch>
-        </p:blipFill>
-        <p:spPr>
-          <a:xfrm>
-            <a:off x="7086600" y="1554480"/>
-            <a:ext cx="4846320" cy="2898705"/>
-          </a:xfrm>
-          <a:prstGeom prst="rect">
-            <a:avLst/>
-          </a:prstGeom>
-        </p:spPr>
-      </p:pic>
-      <p:sp>
-        <p:nvSpPr>
-          <p:cNvPr id="6" name="Rounded Rectangle 5"/>
-          <p:cNvSpPr/>
-          <p:nvPr/>
-        </p:nvSpPr>
-        <p:spPr>
-          <a:xfrm>
-            <a:off x="457200" y="4754880"/>
-            <a:ext cx="3246120" cy="960120"/>
+            <a:off x="6537960" y="4617720"/>
+            <a:ext cx="5303520" cy="1810512"/>
           </a:xfrm>
           <a:prstGeom prst="roundRect">
             <a:avLst>
@@ -8626,86 +8774,587 @@
           </a:fontRef>
         </p:style>
         <p:txBody>
-          <a:bodyPr rtlCol="0" anchor="ctr" wrap="square" lIns="137160" rIns="137160" tIns="91440" bIns="91440"/>
+          <a:bodyPr rtlCol="0" anchor="t" wrap="square" lIns="137160" rIns="137160" tIns="91440" bIns="91440"/>
           <a:lstStyle/>
           <a:p>
-            <a:pPr algn="ctr">
+            <a:pPr algn="l">
               <a:spcAft>
                 <a:spcPts val="500"/>
               </a:spcAft>
             </a:pPr>
             <a:r>
-              <a:rPr sz="1200" b="1" i="0">
-                <a:solidFill>
-                  <a:srgbClr val="222222"/>
+              <a:rPr sz="1100" b="1" i="0">
+                <a:solidFill>
+                  <a:srgbClr val="1F4E79"/>
                 </a:solidFill>
                 <a:latin typeface="Arial"/>
               </a:rPr>
-              <a:t>Gold on the LN slab guides a surface wave</a:t>
-            </a:r>
-          </a:p>
-          <a:p>
-            <a:pPr algn="ctr">
+              <a:t>Lateral Fabry–Pérot cavity </a:t>
+            </a:r>
+            <a:r>
+              <a:rPr sz="1100" b="0" i="0">
+                <a:solidFill>
+                  <a:srgbClr val="222222"/>
+                </a:solidFill>
+                <a:latin typeface="Arial"/>
+              </a:rPr>
+              <a:t>(gap edge ↔ gold/oxide step), L = x_lift − gap/2:</a:t>
+            </a:r>
+          </a:p>
+          <a:p>
+            <a:pPr algn="l">
               <a:spcAft>
                 <a:spcPts val="500"/>
               </a:spcAft>
             </a:pPr>
             <a:r>
-              <a:rPr sz="1200" b="1" i="0">
-                <a:solidFill>
-                  <a:srgbClr val="1F4E79"/>
+              <a:rPr sz="1100" b="0" i="0">
+                <a:solidFill>
+                  <a:srgbClr val="222222"/>
                 </a:solidFill>
                 <a:latin typeface="Arial"/>
               </a:rPr>
-              <a:t>n = 2.07 &gt; n_rib = 1.88</a:t>
+              <a:t>IL = IL</a:t>
+            </a:r>
+            <a:r>
+              <a:rPr sz="1100" b="0" i="0" baseline="-25000">
+                <a:solidFill>
+                  <a:srgbClr val="222222"/>
+                </a:solidFill>
+                <a:latin typeface="Arial"/>
+              </a:rPr>
+              <a:t>∞</a:t>
+            </a:r>
+            <a:r>
+              <a:rPr sz="1100" b="0" i="0">
+                <a:solidFill>
+                  <a:srgbClr val="222222"/>
+                </a:solidFill>
+                <a:latin typeface="Arial"/>
+              </a:rPr>
+              <a:t> (1 − ρ²) / (1 − 2ρ cos(2k</a:t>
+            </a:r>
+            <a:r>
+              <a:rPr sz="1100" b="0" i="0" baseline="-25000">
+                <a:solidFill>
+                  <a:srgbClr val="222222"/>
+                </a:solidFill>
+                <a:latin typeface="Arial"/>
+              </a:rPr>
+              <a:t>x</a:t>
+            </a:r>
+            <a:r>
+              <a:rPr sz="1100" b="0" i="0">
+                <a:solidFill>
+                  <a:srgbClr val="222222"/>
+                </a:solidFill>
+                <a:latin typeface="Arial"/>
+              </a:rPr>
+              <a:t>L + φ) + ρ²),   ρ = ρ</a:t>
+            </a:r>
+            <a:r>
+              <a:rPr sz="1100" b="0" i="0" baseline="-25000">
+                <a:solidFill>
+                  <a:srgbClr val="222222"/>
+                </a:solidFill>
+                <a:latin typeface="Arial"/>
+              </a:rPr>
+              <a:t>0</a:t>
+            </a:r>
+            <a:r>
+              <a:rPr sz="1100" b="0" i="0">
+                <a:solidFill>
+                  <a:srgbClr val="222222"/>
+                </a:solidFill>
+                <a:latin typeface="Arial"/>
+              </a:rPr>
+              <a:t> e^(−2α</a:t>
+            </a:r>
+            <a:r>
+              <a:rPr sz="1100" b="0" i="0" baseline="-25000">
+                <a:solidFill>
+                  <a:srgbClr val="222222"/>
+                </a:solidFill>
+                <a:latin typeface="Arial"/>
+              </a:rPr>
+              <a:t>x</a:t>
+            </a:r>
+            <a:r>
+              <a:rPr sz="1100" b="0" i="0">
+                <a:solidFill>
+                  <a:srgbClr val="222222"/>
+                </a:solidFill>
+                <a:latin typeface="Arial"/>
+              </a:rPr>
+              <a:t>L)</a:t>
+            </a:r>
+          </a:p>
+          <a:p>
+            <a:pPr algn="l">
+              <a:spcAft>
+                <a:spcPts val="500"/>
+              </a:spcAft>
+            </a:pPr>
+            <a:r>
+              <a:rPr sz="1100" b="0" i="0">
+                <a:solidFill>
+                  <a:srgbClr val="222222"/>
+                </a:solidFill>
+                <a:latin typeface="Arial"/>
+              </a:rPr>
+              <a:t>k</a:t>
+            </a:r>
+            <a:r>
+              <a:rPr sz="1100" b="0" i="0" baseline="-25000">
+                <a:solidFill>
+                  <a:srgbClr val="222222"/>
+                </a:solidFill>
+                <a:latin typeface="Arial"/>
+              </a:rPr>
+              <a:t>x</a:t>
+            </a:r>
+            <a:r>
+              <a:rPr sz="1100" b="0" i="0">
+                <a:solidFill>
+                  <a:srgbClr val="222222"/>
+                </a:solidFill>
+                <a:latin typeface="Arial"/>
+              </a:rPr>
+              <a:t>, α</a:t>
+            </a:r>
+            <a:r>
+              <a:rPr sz="1100" b="0" i="0" baseline="-25000">
+                <a:solidFill>
+                  <a:srgbClr val="222222"/>
+                </a:solidFill>
+                <a:latin typeface="Arial"/>
+              </a:rPr>
+              <a:t>x</a:t>
+            </a:r>
+            <a:r>
+              <a:rPr sz="1100" b="0" i="0">
+                <a:solidFill>
+                  <a:srgbClr val="222222"/>
+                </a:solidFill>
+                <a:latin typeface="Arial"/>
+              </a:rPr>
+              <a:t>: lateral wavenumber and gold absorption of the wave under the gold. Envelopes IL</a:t>
+            </a:r>
+            <a:r>
+              <a:rPr sz="1100" b="0" i="0" baseline="-25000">
+                <a:solidFill>
+                  <a:srgbClr val="222222"/>
+                </a:solidFill>
+                <a:latin typeface="Arial"/>
+              </a:rPr>
+              <a:t>∞</a:t>
+            </a:r>
+            <a:r>
+              <a:rPr sz="1100" b="0" i="0">
+                <a:solidFill>
+                  <a:srgbClr val="222222"/>
+                </a:solidFill>
+                <a:latin typeface="Arial"/>
+              </a:rPr>
+              <a:t>(1 ± ρ)/(1 ∓ ρ) converge to IL</a:t>
+            </a:r>
+            <a:r>
+              <a:rPr sz="1100" b="0" i="0" baseline="-25000">
+                <a:solidFill>
+                  <a:srgbClr val="222222"/>
+                </a:solidFill>
+                <a:latin typeface="Arial"/>
+              </a:rPr>
+              <a:t>∞</a:t>
+            </a:r>
+            <a:r>
+              <a:rPr sz="1100" b="0" i="0">
+                <a:solidFill>
+                  <a:srgbClr val="222222"/>
+                </a:solidFill>
+                <a:latin typeface="Arial"/>
+              </a:rPr>
+              <a:t>.</a:t>
+            </a:r>
+          </a:p>
+          <a:p>
+            <a:pPr algn="l">
+              <a:spcAft>
+                <a:spcPts val="500"/>
+              </a:spcAft>
+            </a:pPr>
+            <a:r>
+              <a:rPr sz="1100" b="1" i="0">
+                <a:solidFill>
+                  <a:srgbClr val="1F4E79"/>
+                </a:solidFill>
+                <a:latin typeface="Arial"/>
+              </a:rPr>
+              <a:t>Fit (rms 0.002 dB/cm): </a:t>
+            </a:r>
+            <a:r>
+              <a:rPr sz="1100" b="0" i="0">
+                <a:solidFill>
+                  <a:srgbClr val="222222"/>
+                </a:solidFill>
+                <a:latin typeface="Arial"/>
+              </a:rPr>
+              <a:t>IL</a:t>
+            </a:r>
+            <a:r>
+              <a:rPr sz="1100" b="0" i="0" baseline="-25000">
+                <a:solidFill>
+                  <a:srgbClr val="222222"/>
+                </a:solidFill>
+                <a:latin typeface="Arial"/>
+              </a:rPr>
+              <a:t>∞</a:t>
+            </a:r>
+            <a:r>
+              <a:rPr sz="1100" b="0" i="0">
+                <a:solidFill>
+                  <a:srgbClr val="222222"/>
+                </a:solidFill>
+                <a:latin typeface="Arial"/>
+              </a:rPr>
+              <a:t> = 0.41 dB/cm (Cordoba 0.42); 2α</a:t>
+            </a:r>
+            <a:r>
+              <a:rPr sz="1100" b="0" i="0" baseline="-25000">
+                <a:solidFill>
+                  <a:srgbClr val="222222"/>
+                </a:solidFill>
+                <a:latin typeface="Arial"/>
+              </a:rPr>
+              <a:t>x</a:t>
+            </a:r>
+            <a:r>
+              <a:rPr sz="1100" b="0" i="0">
+                <a:solidFill>
+                  <a:srgbClr val="222222"/>
+                </a:solidFill>
+                <a:latin typeface="Arial"/>
+              </a:rPr>
+              <a:t> = 0.175 µm⁻¹, π/k</a:t>
+            </a:r>
+            <a:r>
+              <a:rPr sz="1100" b="0" i="0" baseline="-25000">
+                <a:solidFill>
+                  <a:srgbClr val="222222"/>
+                </a:solidFill>
+                <a:latin typeface="Arial"/>
+              </a:rPr>
+              <a:t>x</a:t>
+            </a:r>
+            <a:r>
+              <a:rPr sz="1100" b="0" i="0">
+                <a:solidFill>
+                  <a:srgbClr val="222222"/>
+                </a:solidFill>
+                <a:latin typeface="Arial"/>
+              </a:rPr>
+              <a:t> = 0.895 µm, vs 0.181 µm⁻¹ and 0.91 µm predicted by its 1D index.</a:t>
             </a:r>
           </a:p>
         </p:txBody>
       </p:sp>
-      <p:sp>
-        <p:nvSpPr>
-          <p:cNvPr id="7" name="Right Arrow 6"/>
-          <p:cNvSpPr/>
+    </p:spTree>
+  </p:cSld>
+  <p:clrMapOvr>
+    <a:masterClrMapping/>
+  </p:clrMapOvr>
+</p:sld>
+</file>
+
+<file path=ppt/slides/slide3.xml><?xml version="1.0" encoding="utf-8"?>
+<p:sld xmlns:a="http://schemas.openxmlformats.org/drawingml/2006/main" xmlns:p="http://schemas.openxmlformats.org/presentationml/2006/main" xmlns:r="http://schemas.openxmlformats.org/officeDocument/2006/relationships">
+  <p:cSld>
+    <p:spTree>
+      <p:nvGrpSpPr>
+        <p:cNvPr id="1" name=""/>
+        <p:cNvGrpSpPr/>
+        <p:nvPr/>
+      </p:nvGrpSpPr>
+      <p:grpSpPr/>
+      <p:sp>
+        <p:nvSpPr>
+          <p:cNvPr id="2" name="TextBox 1"/>
+          <p:cNvSpPr txBox="1"/>
           <p:nvPr/>
         </p:nvSpPr>
         <p:spPr>
           <a:xfrm>
-            <a:off x="3794760" y="5084064"/>
-            <a:ext cx="320040" cy="292608"/>
+            <a:off x="502920" y="475488"/>
+            <a:ext cx="10241280" cy="685800"/>
           </a:xfrm>
-          <a:prstGeom prst="rightArrow">
+          <a:prstGeom prst="rect">
             <a:avLst/>
           </a:prstGeom>
-          <a:solidFill>
-            <a:srgbClr val="1F4E79"/>
-          </a:solidFill>
-          <a:ln>
-            <a:noFill/>
-          </a:ln>
-          <a:effectLst/>
+          <a:noFill/>
         </p:spPr>
-        <p:style>
-          <a:lnRef idx="1">
-            <a:schemeClr val="accent1"/>
-          </a:lnRef>
-          <a:fillRef idx="3">
-            <a:schemeClr val="accent1"/>
-          </a:fillRef>
-          <a:effectRef idx="2">
-            <a:schemeClr val="accent1"/>
-          </a:effectRef>
-          <a:fontRef idx="minor">
-            <a:schemeClr val="lt1"/>
-          </a:fontRef>
-        </p:style>
         <p:txBody>
-          <a:bodyPr rtlCol="0" anchor="ctr"/>
+          <a:bodyPr wrap="square" lIns="45720" rIns="45720" tIns="27432" bIns="27432" anchor="ctr">
+            <a:spAutoFit/>
+          </a:bodyPr>
           <a:lstStyle/>
           <a:p>
-            <a:pPr algn="ctr"/>
+            <a:pPr algn="l">
+              <a:spcAft>
+                <a:spcPts val="600"/>
+              </a:spcAft>
+            </a:pPr>
+            <a:r>
+              <a:rPr sz="3000" b="0" i="0">
+                <a:solidFill>
+                  <a:srgbClr val="222222"/>
+                </a:solidFill>
+                <a:latin typeface="Arial"/>
+              </a:rPr>
+              <a:t>Origin: a standing wave in a lateral cavity under the gold</a:t>
+            </a:r>
           </a:p>
         </p:txBody>
       </p:sp>
+      <p:sp>
+        <p:nvSpPr>
+          <p:cNvPr id="3" name="TextBox 2"/>
+          <p:cNvSpPr txBox="1"/>
+          <p:nvPr/>
+        </p:nvSpPr>
+        <p:spPr>
+          <a:xfrm>
+            <a:off x="502920" y="1115568"/>
+            <a:ext cx="10789920" cy="411480"/>
+          </a:xfrm>
+          <a:prstGeom prst="rect">
+            <a:avLst/>
+          </a:prstGeom>
+          <a:noFill/>
+        </p:spPr>
+        <p:txBody>
+          <a:bodyPr wrap="square" lIns="45720" rIns="45720" tIns="27432" bIns="27432" anchor="t">
+            <a:spAutoFit/>
+          </a:bodyPr>
+          <a:lstStyle/>
+          <a:p>
+            <a:pPr algn="l">
+              <a:spcAft>
+                <a:spcPts val="600"/>
+              </a:spcAft>
+            </a:pPr>
+            <a:r>
+              <a:rPr sz="1500" b="0" i="1">
+                <a:solidFill>
+                  <a:srgbClr val="595959"/>
+                </a:solidFill>
+                <a:latin typeface="Arial"/>
+              </a:rPr>
+              <a:t>Only the gold-covered slab carries a lateral wave faster than the rib mode; the lift closes the cavity</a:t>
+            </a:r>
+          </a:p>
+        </p:txBody>
+      </p:sp>
+      <p:pic>
+        <p:nvPicPr>
+          <p:cNvPr id="4" name="Picture 3" descr="image5.png"/>
+          <p:cNvPicPr>
+            <a:picLocks noChangeAspect="1"/>
+          </p:cNvPicPr>
+          <p:nvPr/>
+        </p:nvPicPr>
+        <p:blipFill>
+          <a:blip r:embed="rId2"/>
+          <a:stretch>
+            <a:fillRect/>
+          </a:stretch>
+        </p:blipFill>
+        <p:spPr>
+          <a:xfrm>
+            <a:off x="365760" y="1481328"/>
+            <a:ext cx="5486400" cy="2231699"/>
+          </a:xfrm>
+          <a:prstGeom prst="rect">
+            <a:avLst/>
+          </a:prstGeom>
+        </p:spPr>
+      </p:pic>
+      <p:pic>
+        <p:nvPicPr>
+          <p:cNvPr id="5" name="Picture 4" descr="index_profile.png"/>
+          <p:cNvPicPr>
+            <a:picLocks noChangeAspect="1"/>
+          </p:cNvPicPr>
+          <p:nvPr/>
+        </p:nvPicPr>
+        <p:blipFill>
+          <a:blip r:embed="rId3"/>
+          <a:stretch>
+            <a:fillRect/>
+          </a:stretch>
+        </p:blipFill>
+        <p:spPr>
+          <a:xfrm>
+            <a:off x="365760" y="3749039"/>
+            <a:ext cx="5852160" cy="2377440"/>
+          </a:xfrm>
+          <a:prstGeom prst="rect">
+            <a:avLst/>
+          </a:prstGeom>
+        </p:spPr>
+      </p:pic>
+      <p:sp>
+        <p:nvSpPr>
+          <p:cNvPr id="6" name="TextBox 5"/>
+          <p:cNvSpPr txBox="1"/>
+          <p:nvPr/>
+        </p:nvSpPr>
+        <p:spPr>
+          <a:xfrm>
+            <a:off x="365760" y="6144768"/>
+            <a:ext cx="5897880" cy="457200"/>
+          </a:xfrm>
+          <a:prstGeom prst="rect">
+            <a:avLst/>
+          </a:prstGeom>
+          <a:noFill/>
+        </p:spPr>
+        <p:txBody>
+          <a:bodyPr wrap="square" lIns="45720" rIns="45720" tIns="27432" bIns="27432" anchor="t">
+            <a:spAutoFit/>
+          </a:bodyPr>
+          <a:lstStyle/>
+          <a:p>
+            <a:pPr algn="l">
+              <a:spcAft>
+                <a:spcPts val="600"/>
+              </a:spcAft>
+            </a:pPr>
+            <a:r>
+              <a:rPr sz="1000" b="0" i="0">
+                <a:solidFill>
+                  <a:srgbClr val="595959"/>
+                </a:solidFill>
+                <a:latin typeface="Arial"/>
+              </a:rPr>
+              <a:t>Index of each vertical stack (1D mode solve) vs the 2D rib mode: n &gt; n</a:t>
+            </a:r>
+            <a:r>
+              <a:rPr sz="1000" b="0" i="0" baseline="-25000">
+                <a:solidFill>
+                  <a:srgbClr val="595959"/>
+                </a:solidFill>
+                <a:latin typeface="Arial"/>
+              </a:rPr>
+              <a:t>rib</a:t>
+            </a:r>
+            <a:r>
+              <a:rPr sz="1000" b="0" i="0">
+                <a:solidFill>
+                  <a:srgbClr val="595959"/>
+                </a:solidFill>
+                <a:latin typeface="Arial"/>
+              </a:rPr>
+              <a:t> → k</a:t>
+            </a:r>
+            <a:r>
+              <a:rPr sz="1000" b="0" i="0" baseline="-25000">
+                <a:solidFill>
+                  <a:srgbClr val="595959"/>
+                </a:solidFill>
+                <a:latin typeface="Arial"/>
+              </a:rPr>
+              <a:t>x</a:t>
+            </a:r>
+            <a:r>
+              <a:rPr sz="1000" b="0" i="0">
+                <a:solidFill>
+                  <a:srgbClr val="595959"/>
+                </a:solidFill>
+                <a:latin typeface="Arial"/>
+              </a:rPr>
+              <a:t> = k</a:t>
+            </a:r>
+            <a:r>
+              <a:rPr sz="1000" b="0" i="0" baseline="-25000">
+                <a:solidFill>
+                  <a:srgbClr val="595959"/>
+                </a:solidFill>
+                <a:latin typeface="Arial"/>
+              </a:rPr>
+              <a:t>0</a:t>
+            </a:r>
+            <a:r>
+              <a:rPr sz="1000" b="0" i="0">
+                <a:solidFill>
+                  <a:srgbClr val="595959"/>
+                </a:solidFill>
+                <a:latin typeface="Arial"/>
+              </a:rPr>
+              <a:t>√(n² − n</a:t>
+            </a:r>
+            <a:r>
+              <a:rPr sz="1000" b="0" i="0" baseline="-25000">
+                <a:solidFill>
+                  <a:srgbClr val="595959"/>
+                </a:solidFill>
+                <a:latin typeface="Arial"/>
+              </a:rPr>
+              <a:t>rib</a:t>
+            </a:r>
+            <a:r>
+              <a:rPr sz="1000" b="0" i="0">
+                <a:solidFill>
+                  <a:srgbClr val="595959"/>
+                </a:solidFill>
+                <a:latin typeface="Arial"/>
+              </a:rPr>
+              <a:t>²) real, the wave propagates sideways; n &lt; n</a:t>
+            </a:r>
+            <a:r>
+              <a:rPr sz="1000" b="0" i="0" baseline="-25000">
+                <a:solidFill>
+                  <a:srgbClr val="595959"/>
+                </a:solidFill>
+                <a:latin typeface="Arial"/>
+              </a:rPr>
+              <a:t>rib</a:t>
+            </a:r>
+            <a:r>
+              <a:rPr sz="1000" b="0" i="0">
+                <a:solidFill>
+                  <a:srgbClr val="595959"/>
+                </a:solidFill>
+                <a:latin typeface="Arial"/>
+              </a:rPr>
+              <a:t> → cut off, the wave is reflected.</a:t>
+            </a:r>
+          </a:p>
+        </p:txBody>
+      </p:sp>
+      <p:pic>
+        <p:nvPicPr>
+          <p:cNvPr id="7" name="Picture 6" descr="fieldmaps2.png"/>
+          <p:cNvPicPr>
+            <a:picLocks noChangeAspect="1"/>
+          </p:cNvPicPr>
+          <p:nvPr/>
+        </p:nvPicPr>
+        <p:blipFill>
+          <a:blip r:embed="rId4"/>
+          <a:stretch>
+            <a:fillRect/>
+          </a:stretch>
+        </p:blipFill>
+        <p:spPr>
+          <a:xfrm>
+            <a:off x="6355080" y="1463040"/>
+            <a:ext cx="5486400" cy="3670578"/>
+          </a:xfrm>
+          <a:prstGeom prst="rect">
+            <a:avLst/>
+          </a:prstGeom>
+        </p:spPr>
+      </p:pic>
       <p:sp>
         <p:nvSpPr>
           <p:cNvPr id="8" name="Rounded Rectangle 7"/>
@@ -8714,8 +9363,8 @@
         </p:nvSpPr>
         <p:spPr>
           <a:xfrm>
-            <a:off x="4206240" y="4754880"/>
-            <a:ext cx="3246120" cy="960120"/>
+            <a:off x="6355080" y="5230368"/>
+            <a:ext cx="5486400" cy="1298448"/>
           </a:xfrm>
           <a:prstGeom prst="roundRect">
             <a:avLst>
@@ -8745,10 +9394,10 @@
           </a:fontRef>
         </p:style>
         <p:txBody>
-          <a:bodyPr rtlCol="0" anchor="ctr" wrap="square" lIns="137160" rIns="137160" tIns="91440" bIns="91440"/>
+          <a:bodyPr rtlCol="0" anchor="t" wrap="square" lIns="137160" rIns="137160" tIns="91440" bIns="91440"/>
           <a:lstStyle/>
           <a:p>
-            <a:pPr algn="ctr">
+            <a:pPr algn="l">
               <a:spcAft>
                 <a:spcPts val="500"/>
               </a:spcAft>
@@ -8756,185 +9405,99 @@
             <a:r>
               <a:rPr sz="1200" b="1" i="0">
                 <a:solidFill>
-                  <a:srgbClr val="222222"/>
+                  <a:srgbClr val="1F4E79"/>
                 </a:solidFill>
                 <a:latin typeface="Arial"/>
               </a:rPr>
-              <a:t>The rib mode leaks into it; the wave travels sideways</a:t>
-            </a:r>
-          </a:p>
-          <a:p>
-            <a:pPr algn="ctr">
+              <a:t>Why 0.9 µm? </a:t>
+            </a:r>
+            <a:r>
+              <a:rPr sz="1200" b="0" i="0">
+                <a:solidFill>
+                  <a:srgbClr val="222222"/>
+                </a:solidFill>
+                <a:latin typeface="Arial"/>
+              </a:rPr>
+              <a:t>Λ = λ / (2√(n</a:t>
+            </a:r>
+            <a:r>
+              <a:rPr sz="1200" b="0" i="0" baseline="-25000">
+                <a:solidFill>
+                  <a:srgbClr val="222222"/>
+                </a:solidFill>
+                <a:latin typeface="Arial"/>
+              </a:rPr>
+              <a:t>Au</a:t>
+            </a:r>
+            <a:r>
+              <a:rPr sz="1200" b="0" i="0">
+                <a:solidFill>
+                  <a:srgbClr val="222222"/>
+                </a:solidFill>
+                <a:latin typeface="Arial"/>
+              </a:rPr>
+              <a:t>² − n</a:t>
+            </a:r>
+            <a:r>
+              <a:rPr sz="1200" b="0" i="0" baseline="-25000">
+                <a:solidFill>
+                  <a:srgbClr val="222222"/>
+                </a:solidFill>
+                <a:latin typeface="Arial"/>
+              </a:rPr>
+              <a:t>rib</a:t>
+            </a:r>
+            <a:r>
+              <a:rPr sz="1200" b="0" i="0">
+                <a:solidFill>
+                  <a:srgbClr val="222222"/>
+                </a:solidFill>
+                <a:latin typeface="Arial"/>
+              </a:rPr>
+              <a:t>²)) = 1.575 / (2 × 0.863) = 0.91 µm (simulated 0.90): half the lateral wavelength, set by the indices only.</a:t>
+            </a:r>
+          </a:p>
+          <a:p>
+            <a:pPr algn="l">
               <a:spcAft>
                 <a:spcPts val="500"/>
               </a:spcAft>
             </a:pPr>
             <a:r>
-              <a:rPr sz="1200" b="0" i="0">
-                <a:solidFill>
-                  <a:srgbClr val="222222"/>
+              <a:rPr sz="1200" b="1" i="0">
+                <a:solidFill>
+                  <a:srgbClr val="1F4E79"/>
                 </a:solidFill>
                 <a:latin typeface="Arial"/>
               </a:rPr>
-              <a:t>and is reflected at the gold/oxide step</a:t>
-            </a:r>
-          </a:p>
-        </p:txBody>
-      </p:sp>
-      <p:sp>
-        <p:nvSpPr>
-          <p:cNvPr id="9" name="Right Arrow 8"/>
-          <p:cNvSpPr/>
-          <p:nvPr/>
-        </p:nvSpPr>
-        <p:spPr>
-          <a:xfrm>
-            <a:off x="7543800" y="5084064"/>
-            <a:ext cx="320040" cy="292608"/>
-          </a:xfrm>
-          <a:prstGeom prst="rightArrow">
-            <a:avLst/>
-          </a:prstGeom>
-          <a:solidFill>
-            <a:srgbClr val="1F4E79"/>
-          </a:solidFill>
-          <a:ln>
-            <a:noFill/>
-          </a:ln>
-          <a:effectLst/>
-        </p:spPr>
-        <p:style>
-          <a:lnRef idx="1">
-            <a:schemeClr val="accent1"/>
-          </a:lnRef>
-          <a:fillRef idx="3">
-            <a:schemeClr val="accent1"/>
-          </a:fillRef>
-          <a:effectRef idx="2">
-            <a:schemeClr val="accent1"/>
-          </a:effectRef>
-          <a:fontRef idx="minor">
-            <a:schemeClr val="lt1"/>
-          </a:fontRef>
-        </p:style>
-        <p:txBody>
-          <a:bodyPr rtlCol="0" anchor="ctr"/>
-          <a:lstStyle/>
-          <a:p>
-            <a:pPr algn="ctr"/>
-          </a:p>
-        </p:txBody>
-      </p:sp>
-      <p:sp>
-        <p:nvSpPr>
-          <p:cNvPr id="10" name="Rounded Rectangle 9"/>
-          <p:cNvSpPr/>
-          <p:nvPr/>
-        </p:nvSpPr>
-        <p:spPr>
-          <a:xfrm>
-            <a:off x="7955279" y="4754880"/>
-            <a:ext cx="3794760" cy="960120"/>
-          </a:xfrm>
-          <a:prstGeom prst="roundRect">
-            <a:avLst>
-              <a:gd name="adj" fmla="val 6000"/>
-            </a:avLst>
-          </a:prstGeom>
-          <a:solidFill>
-            <a:srgbClr val="FDE9D9"/>
-          </a:solidFill>
-          <a:ln>
-            <a:noFill/>
-          </a:ln>
-          <a:effectLst/>
-        </p:spPr>
-        <p:style>
-          <a:lnRef idx="1">
-            <a:schemeClr val="accent1"/>
-          </a:lnRef>
-          <a:fillRef idx="3">
-            <a:schemeClr val="accent1"/>
-          </a:fillRef>
-          <a:effectRef idx="2">
-            <a:schemeClr val="accent1"/>
-          </a:effectRef>
-          <a:fontRef idx="minor">
-            <a:schemeClr val="lt1"/>
-          </a:fontRef>
-        </p:style>
-        <p:txBody>
-          <a:bodyPr rtlCol="0" anchor="ctr" wrap="square" lIns="137160" rIns="137160" tIns="91440" bIns="91440"/>
-          <a:lstStyle/>
-          <a:p>
-            <a:pPr algn="ctr">
-              <a:spcAft>
-                <a:spcPts val="500"/>
-              </a:spcAft>
-            </a:pPr>
-            <a:r>
-              <a:rPr sz="1200" b="1" i="0">
+              <a:t>Cavity length: </a:t>
+            </a:r>
+            <a:r>
+              <a:rPr sz="1200" b="0" i="0">
                 <a:solidFill>
                   <a:srgbClr val="222222"/>
                 </a:solidFill>
                 <a:latin typeface="Arial"/>
               </a:rPr>
-              <a:t>Standing wave: period 0.9 µm</a:t>
-            </a:r>
-          </a:p>
-          <a:p>
-            <a:pPr algn="ctr">
-              <a:spcAft>
-                <a:spcPts val="500"/>
-              </a:spcAft>
-            </a:pPr>
-            <a:r>
-              <a:rPr sz="1200" b="0" i="0">
+              <a:t>sets how many half-waves fit (≈ 5 at 7 µm). Resonance 2k</a:t>
+            </a:r>
+            <a:r>
+              <a:rPr sz="1200" b="0" i="0" baseline="-25000">
                 <a:solidFill>
                   <a:srgbClr val="222222"/>
                 </a:solidFill>
                 <a:latin typeface="Arial"/>
               </a:rPr>
-              <a:t>IL peaks when x_lift makes the cavity resonant</a:t>
-            </a:r>
-          </a:p>
-        </p:txBody>
-      </p:sp>
-      <p:sp>
-        <p:nvSpPr>
-          <p:cNvPr id="11" name="TextBox 10"/>
-          <p:cNvSpPr txBox="1"/>
-          <p:nvPr/>
-        </p:nvSpPr>
-        <p:spPr>
-          <a:xfrm>
-            <a:off x="457200" y="5852160"/>
-            <a:ext cx="11338560" cy="365760"/>
-          </a:xfrm>
-          <a:prstGeom prst="rect">
-            <a:avLst/>
-          </a:prstGeom>
-          <a:noFill/>
-        </p:spPr>
-        <p:txBody>
-          <a:bodyPr wrap="square" lIns="45720" rIns="45720" tIns="27432" bIns="27432" anchor="t">
-            <a:spAutoFit/>
-          </a:bodyPr>
-          <a:lstStyle/>
-          <a:p>
-            <a:pPr algn="l">
-              <a:spcAft>
-                <a:spcPts val="600"/>
-              </a:spcAft>
-            </a:pPr>
-            <a:r>
-              <a:rPr sz="1200" b="0" i="1">
-                <a:solidFill>
-                  <a:srgbClr val="595959"/>
+              <a:t>x</a:t>
+            </a:r>
+            <a:r>
+              <a:rPr sz="1200" b="0" i="0">
+                <a:solidFill>
+                  <a:srgbClr val="222222"/>
                 </a:solidFill>
                 <a:latin typeface="Arial"/>
               </a:rPr>
-              <a:t>Cordoba: no step, so the wave simply travels away and is absorbed: smooth curve, no x_lift dependence.</a:t>
+              <a:t>L + φ = 2πm recurs every ΔL = Λ: one more half-wave per 0.9 µm of x_lift.</a:t>
             </a:r>
           </a:p>
         </p:txBody>

</xml_diff>